<commit_message>
talk: deck v2 (20 slides) — PowerTCP endemic numbers, corrected makespan (-14%), 30-phase pipelined collective notes, data DOI on closing slide, new dataplane-feasibility backup slide; README: raw-data mirrors (Zenodo DOI + release)
</commit_message>
<xml_diff>
--- a/examples/hpcc/hpcc-fs/talk/ipccc2026-talk.pptx
+++ b/examples/hpcc/hpcc-fs/talk/ipccc2026-talk.pptx
@@ -24,9 +24,10 @@
     <p:sldId id="272" r:id="rId18"/>
     <p:sldId id="273" r:id="rId19"/>
     <p:sldId id="274" r:id="rId20"/>
+    <p:sldId id="275" r:id="rId21"/>
   </p:sldIdLst>
   <p:notesMasterIdLst>
-    <p:notesMasterId r:id="rId21"/>
+    <p:notesMasterId r:id="rId22"/>
   </p:notesMasterIdLst>
   <p:sldSz cx="9144000" cy="5143500"/>
   <p:notesSz cx="5143500" cy="9144000"/>
@@ -1753,7 +1754,7 @@
           <a:p>
             <a:r>
               <a:rPr lang="en-US" dirty="0"/>
-              <a:t>The headline — and it is not just HPCC: on the same benchmark DCQCN runs 1.7 to 2.3, TIMELY 1.8 to 2.0, DCTCP 1.6 to 1.8, all growing with N. Multi-bottleneck unfairness is endemic to deployable RDMA CC. Blue bars: RDMA-RCP sits at 1.003 to 1.007 across the entire sweep — including N of 5 and 6 where stock HPCC's wire format breaks, because one field doesn't grow with path length. Zero PFC everywhere. And an important control: HPCC-PINT, which also carries a single compressed field but still carries *load*, stays at 1.8x — so it's not about telemetry size, it's about carrying a fair share instead of a load sample.</a:t>
+              <a:t>The headline — and it is not just HPCC: on the same benchmark DCQCN runs 1.7 to 2.3, TIMELY 1.8 to 2.0, DCTCP 1.6 to 1.8, PowerTCP — ported from the authors' own code — 1.8 to 1.9, all growing with N. Multi-bottleneck unfairness is endemic to deployable RDMA CC. Blue bars: RDMA-RCP sits at 1.003 to 1.007 across the entire sweep — including N of 5 and 6 where stock HPCC's wire format breaks, because one field doesn't grow with path length. Zero PFC everywhere. And an important control: HPCC-PINT, which also carries a single compressed field but still carries *load*, stays at 1.8x — so it's not about telemetry size, it's about carrying a fair share instead of a load sample.</a:t>
             </a:r>
             <a:endParaRPr lang="en-US" dirty="0"/>
           </a:p>
@@ -1929,7 +1930,7 @@
           <a:p>
             <a:r>
               <a:rPr lang="en-US" dirty="0"/>
-              <a:t>So what does fairness buy on a workload operators care about? Collective communication: an allreduce step finishes when its slowest flow finishes, and the slowest flows are exactly the cross-pod multi-bottleneck ones stock HPCC starves. A 16-flow ring coflow — one phase of a ring allreduce — across five ECMP hash seeds: RDMA-RCP cuts completion time 18 to 23 percent at every seed tested, and 18 percent survives padding the INT header to stock size, so the gain is fairness, not header thinness. On a saturating k-equals-6 fabric with 108 inter-pod flows, makespan improves 16 percent. And the short background flows got three times faster — under near-winner-take-all dynamics, a short flow's fate is a placement lottery; max-min removes it.</a:t>
+              <a:t>So what does fairness buy on a workload operators care about? Collective communication: an allreduce step finishes when its slowest flow finishes, and the slowest flows are exactly the cross-pod multi-bottleneck ones stock HPCC starves. A 16-flow ring coflow — one phase of a ring allreduce — across five ECMP hash seeds: RDMA-RCP cuts completion time 18 to 23 percent at every seed tested, and 18 percent survives padding the INT header to stock size, so the gain is fairness, not header thinness. On a saturating k-equals-6 fabric with 108 inter-pod flows, makespan improves 14 percent — 11 with the header padded — with Jain's index rising and zero PFC at 45 switches. And it compounds: the full 30-phase allreduce, scheduled with real per-rank pipelined dependencies rather than global barriers, finishes 21 percent sooner end-to-end — 22 barrier-synchronized, 17 with the padded header — stable across three ECMP placements. And the short background flows got three times faster — under near-winner-take-all dynamics, a short flow's fate is a placement lottery; max-min removes it.</a:t>
             </a:r>
             <a:endParaRPr lang="en-US" dirty="0"/>
           </a:p>
@@ -2105,7 +2106,7 @@
           <a:p>
             <a:r>
               <a:rPr lang="en-US" dirty="0"/>
-              <a:t>We are deliberately explicit about scope. The mechanism is RCP — our contribution is showing where the fix has to live and that placing it there is cheap. The evaluation is simulation-only; we re-ported the HPCC simulator onto modern ns-3 and verified it reproduces the original paper's baselines before building on it. Convergence is milliseconds, not one round trip. And the natural next step is a hybrid that keeps HPCC's per-flow precision under a fair-rate ceiling — the obstacle is HPCC's NIC-sized window, which is its own interesting problem.</a:t>
+              <a:t>We are deliberately explicit about scope. The mechanism is RCP — our contribution is showing where the fix has to live and that placing it there is cheap. The evaluation is simulation-only; we re-ported the HPCC simulator onto modern ns-3 and verified it reproduces the original paper's baselines before building on it. If asked about PowerTCP: it IS evaluated — we ported the authors' reference implementation, validated it solo and pairwise, and it shows the same multi-bottleneck gap, 1.79 to 1.86. Bolt remains the one modern scheme we did not port. Convergence is milliseconds, not one round trip. And the natural next step is a hybrid that keeps HPCC's per-flow precision under a fair-rate ceiling — the obstacle is HPCC's NIC-sized window, which is its own interesting problem.</a:t>
             </a:r>
             <a:endParaRPr lang="en-US" dirty="0"/>
           </a:p>
@@ -2481,6 +2482,94 @@
             <a:fld id="{F7021451-1387-4CA6-816F-3879F97B5CBC}" type="slidenum">
               <a:rPr lang="en-US"/>
               <a:t>2</a:t>
+            </a:fld>
+            <a:endParaRPr lang="en-US"/>
+          </a:p>
+        </p:txBody>
+      </p:sp>
+    </p:spTree>
+    <p:extLst>
+      <p:ext uri="{BB962C8B-B14F-4D97-AF65-F5344CB8AC3E}">
+        <p14:creationId xmlns:p14="http://schemas.microsoft.com/office/powerpoint/2010/main" val="1024086991"/>
+      </p:ext>
+    </p:extLst>
+  </p:cSld>
+  <p:clrMapOvr>
+    <a:masterClrMapping/>
+  </p:clrMapOvr>
+</p:notes>
+</file>
+
+<file path=ppt/notesSlides/notesSlide20.xml><?xml version="1.0" encoding="utf-8"?>
+<p:notes xmlns:a="http://schemas.openxmlformats.org/drawingml/2006/main" xmlns:r="http://schemas.openxmlformats.org/officeDocument/2006/relationships" xmlns:p="http://schemas.openxmlformats.org/presentationml/2006/main">
+  <p:cSld>
+    <p:spTree>
+      <p:nvGrpSpPr>
+        <p:cNvPr id="1" name=""/>
+        <p:cNvGrpSpPr/>
+        <p:nvPr/>
+      </p:nvGrpSpPr>
+      <p:grpSpPr>
+        <a:xfrm>
+          <a:off x="0" y="0"/>
+          <a:ext cx="0" cy="0"/>
+          <a:chOff x="0" y="0"/>
+          <a:chExt cx="0" cy="0"/>
+        </a:xfrm>
+      </p:grpSpPr>
+      <p:sp>
+        <p:nvSpPr>
+          <p:cNvPr id="2" name="Slide Image Placeholder 1"/>
+          <p:cNvSpPr>
+            <a:spLocks noGrp="1" noRot="1" noChangeAspect="1"/>
+          </p:cNvSpPr>
+          <p:nvPr>
+            <p:ph type="sldImg"/>
+          </p:nvPr>
+        </p:nvSpPr>
+        <p:spPr/>
+      </p:sp>
+      <p:sp>
+        <p:nvSpPr>
+          <p:cNvPr id="3" name="Notes Placeholder 2"/>
+          <p:cNvSpPr>
+            <a:spLocks noGrp="1"/>
+          </p:cNvSpPr>
+          <p:nvPr>
+            <p:ph type="body" idx="1"/>
+          </p:nvPr>
+        </p:nvSpPr>
+        <p:spPr/>
+        <p:txBody>
+          <a:bodyPr/>
+          <a:lstStyle/>
+          <a:p>
+            <a:r>
+              <a:rPr lang="en-US" dirty="0"/>
+              <a:t>For the dataplane-feasibility question: we did not build a Tofino prototype, and we say so — whether the interval test and rate update serialize inside one atomic stage is explicitly unverified, as is dequeue-time queue-depth access. What we did do is remove every arithmetic excuse: a divider-free Q16 integer build of the whole update — shift-plus-mantissa reciprocal, max error twenty-five percent — reproduces the headline results within a tenth of a percent penalty. And the exercise caught a genuine deployment hazard: keep the rate register in integer megabits and the floor-recovery path deadlocks — growth truncates to zero below about 2.5 megabits. Units, not width, were the binding choice: kilobit granularity fixes it, and 32 bits of Kbps still spans 4.3 terabits. That hazard is exactly the kind of thing you want to find in simulation before tape-out.</a:t>
+            </a:r>
+            <a:endParaRPr lang="en-US" dirty="0"/>
+          </a:p>
+        </p:txBody>
+      </p:sp>
+      <p:sp>
+        <p:nvSpPr>
+          <p:cNvPr id="4" name="Slide Number Placeholder 3"/>
+          <p:cNvSpPr>
+            <a:spLocks noGrp="1"/>
+          </p:cNvSpPr>
+          <p:nvPr>
+            <p:ph type="sldNum" sz="quarter" idx="10"/>
+          </p:nvPr>
+        </p:nvSpPr>
+        <p:spPr/>
+        <p:txBody>
+          <a:bodyPr/>
+          <a:lstStyle/>
+          <a:p>
+            <a:fld id="{F7021451-1387-4CA6-816F-3879F97B5CBC}" type="slidenum">
+              <a:rPr lang="en-US"/>
+              <a:t>20</a:t>
             </a:fld>
             <a:endParaRPr lang="en-US"/>
           </a:p>
@@ -5919,7 +6008,7 @@
                 <a:ea typeface="Calibri" pitchFamily="34" charset="-122"/>
                 <a:cs typeface="Calibri" pitchFamily="34" charset="-120"/>
               </a:rPr>
-              <a:t>HPCC-PINT (compressed INT) still shows 1.77–1.88× — a smaller footprint is not the fix; a fair-share signal is.</a:t>
+              <a:t>HPCC-PINT (compressed INT): 1.77–1.88× · PowerTCP (NSDI’22): 1.79–1.86× — neither a smaller footprint nor a newer law is the fix; a fair-share signal is.</a:t>
             </a:r>
             <a:endParaRPr lang="en-US" sz="1250" dirty="0"/>
           </a:p>
@@ -8250,7 +8339,7 @@
                 <a:ea typeface="Calibri" pitchFamily="34" charset="-122"/>
                 <a:cs typeface="Calibri" pitchFamily="34" charset="-120"/>
               </a:rPr>
-              <a:t>No testbed; no head-to-head with Bolt / PowerTCP (would require re-implementing them). The simulator re-port reproduces the original HPCC baselines end-to-end.</a:t>
+              <a:t>No testbed; no head-to-head with Bolt. PowerTCP — ported from the authors’ reference code and port-validated — is in the endemic table at 1.79–1.86×. The simulator re-port reproduces the original HPCC baselines end-to-end.</a:t>
             </a:r>
             <a:endParaRPr lang="en-US" sz="1400" dirty="0"/>
           </a:p>
@@ -8668,7 +8757,7 @@
                 <a:ea typeface="Calibri" pitchFamily="34" charset="-122"/>
                 <a:cs typeface="Calibri" pitchFamily="34" charset="-120"/>
               </a:rPr>
-              <a:t>HPCC starves multi-bottleneck flows ~2× (3.5× small flows); breaks past 4 hops. Zero PFC — it’s the equilibrium.</a:t>
+              <a:t>Every evaluated scheme is unfair to the multi-bottleneck flow (1.6–2.3× — DCQCN, TIMELY, DCTCP, HPCC, PowerTCP); HPCC is near-winner-take-all (3.5× small flows), breaks past 4 hops. Zero PFC — it’s the equilibrium.</a:t>
             </a:r>
             <a:endParaRPr lang="en-US" sz="1300" dirty="0"/>
           </a:p>
@@ -8907,7 +8996,7 @@
                 <a:ea typeface="Calibri" pitchFamily="34" charset="-122"/>
                 <a:cs typeface="Calibri" pitchFamily="34" charset="-120"/>
               </a:rPr>
-              <a:t>Artifact (code · paper · reproduction · data):  </a:t>
+              <a:t>Artifact: </a:t>
             </a:r>
             <a:pPr algn="ctr" indent="0" marL="0">
               <a:buNone/>
@@ -8922,6 +9011,34 @@
                 <a:cs typeface="Courier New" pitchFamily="34" charset="-120"/>
               </a:rPr>
               <a:t>github.com/UNOCourseDemo/hpcc-fs</a:t>
+            </a:r>
+            <a:pPr algn="ctr" indent="0" marL="0">
+              <a:buNone/>
+            </a:pPr>
+            <a:r>
+              <a:rPr lang="en-US" sz="1250" dirty="0">
+                <a:solidFill>
+                  <a:srgbClr val="9DB2D8"/>
+                </a:solidFill>
+                <a:latin typeface="Calibri" pitchFamily="34" charset="0"/>
+                <a:ea typeface="Calibri" pitchFamily="34" charset="-122"/>
+                <a:cs typeface="Calibri" pitchFamily="34" charset="-120"/>
+              </a:rPr>
+              <a:t>   ·   raw data DOI </a:t>
+            </a:r>
+            <a:pPr algn="ctr" indent="0" marL="0">
+              <a:buNone/>
+            </a:pPr>
+            <a:r>
+              <a:rPr lang="en-US" sz="1250" b="1" dirty="0">
+                <a:solidFill>
+                  <a:srgbClr val="CADCFC"/>
+                </a:solidFill>
+                <a:latin typeface="Courier New" pitchFamily="34" charset="0"/>
+                <a:ea typeface="Courier New" pitchFamily="34" charset="-122"/>
+                <a:cs typeface="Courier New" pitchFamily="34" charset="-120"/>
+              </a:rPr>
+              <a:t>10.6084/m9.figshare.34330836</a:t>
             </a:r>
             <a:endParaRPr lang="en-US" sz="1250" dirty="0"/>
           </a:p>
@@ -12017,6 +12134,657 @@
               <a:t>The catch: the sender sees load, not its fair share.</a:t>
             </a:r>
             <a:endParaRPr lang="en-US" sz="1500" dirty="0"/>
+          </a:p>
+        </p:txBody>
+      </p:sp>
+    </p:spTree>
+  </p:cSld>
+  <p:clrMapOvr>
+    <a:masterClrMapping/>
+  </p:clrMapOvr>
+</p:sld>
+</file>
+
+<file path=ppt/slides/slide20.xml><?xml version="1.0" encoding="utf-8"?>
+<p:sld xmlns:a="http://schemas.openxmlformats.org/drawingml/2006/main" xmlns:r="http://schemas.openxmlformats.org/officeDocument/2006/relationships" xmlns:p="http://schemas.openxmlformats.org/presentationml/2006/main">
+  <p:cSld name="Slide 20">
+    <p:bg>
+      <p:bgPr>
+        <a:solidFill>
+          <a:srgbClr val="FFFFFF"/>
+        </a:solidFill>
+      </p:bgPr>
+    </p:bg>
+    <p:spTree>
+      <p:nvGrpSpPr>
+        <p:cNvPr id="1" name=""/>
+        <p:cNvGrpSpPr/>
+        <p:nvPr/>
+      </p:nvGrpSpPr>
+      <p:grpSpPr>
+        <a:xfrm>
+          <a:off x="0" y="0"/>
+          <a:ext cx="0" cy="0"/>
+          <a:chOff x="0" y="0"/>
+          <a:chExt cx="0" cy="0"/>
+        </a:xfrm>
+      </p:grpSpPr>
+      <p:sp>
+        <p:nvSpPr>
+          <p:cNvPr id="2" name="Text 0"/>
+          <p:cNvSpPr/>
+          <p:nvPr/>
+        </p:nvSpPr>
+        <p:spPr>
+          <a:xfrm>
+            <a:off x="502920" y="256032"/>
+            <a:ext cx="8138160" cy="274320"/>
+          </a:xfrm>
+          <a:prstGeom prst="rect">
+            <a:avLst/>
+          </a:prstGeom>
+          <a:noFill/>
+          <a:ln/>
+        </p:spPr>
+        <p:txBody>
+          <a:bodyPr wrap="square" lIns="0" tIns="0" rIns="0" bIns="0" rtlCol="0" anchor="ctr"/>
+          <a:lstStyle/>
+          <a:p>
+            <a:pPr indent="0" marL="0">
+              <a:buNone/>
+            </a:pPr>
+            <a:r>
+              <a:rPr lang="en-US" sz="1100" b="1" spc="300" kern="0" dirty="0">
+                <a:solidFill>
+                  <a:srgbClr val="5B6675"/>
+                </a:solidFill>
+                <a:latin typeface="Calibri" pitchFamily="34" charset="0"/>
+                <a:ea typeface="Calibri" pitchFamily="34" charset="-122"/>
+                <a:cs typeface="Calibri" pitchFamily="34" charset="-120"/>
+              </a:rPr>
+              <a:t>BACKUP</a:t>
+            </a:r>
+            <a:endParaRPr lang="en-US" sz="1100" dirty="0"/>
+          </a:p>
+        </p:txBody>
+      </p:sp>
+      <p:sp>
+        <p:nvSpPr>
+          <p:cNvPr id="3" name="Text 1"/>
+          <p:cNvSpPr/>
+          <p:nvPr/>
+        </p:nvSpPr>
+        <p:spPr>
+          <a:xfrm>
+            <a:off x="502920" y="502920"/>
+            <a:ext cx="8138160" cy="566928"/>
+          </a:xfrm>
+          <a:prstGeom prst="rect">
+            <a:avLst/>
+          </a:prstGeom>
+          <a:noFill/>
+          <a:ln/>
+        </p:spPr>
+        <p:txBody>
+          <a:bodyPr wrap="square" lIns="0" tIns="0" rIns="0" bIns="0" rtlCol="0" anchor="ctr"/>
+          <a:lstStyle/>
+          <a:p>
+            <a:pPr indent="0" marL="0">
+              <a:buNone/>
+            </a:pPr>
+            <a:r>
+              <a:rPr lang="en-US" sz="2700" b="1" dirty="0">
+                <a:solidFill>
+                  <a:srgbClr val="1E2761"/>
+                </a:solidFill>
+                <a:latin typeface="Calibri" pitchFamily="34" charset="0"/>
+                <a:ea typeface="Calibri" pitchFamily="34" charset="-122"/>
+                <a:cs typeface="Calibri" pitchFamily="34" charset="-120"/>
+              </a:rPr>
+              <a:t>Can a switch ASIC run this? The Q16 fixed-point check</a:t>
+            </a:r>
+            <a:endParaRPr lang="en-US" sz="2700" dirty="0"/>
+          </a:p>
+        </p:txBody>
+      </p:sp>
+      <p:sp>
+        <p:nvSpPr>
+          <p:cNvPr id="4" name="Shape 2"/>
+          <p:cNvSpPr/>
+          <p:nvPr/>
+        </p:nvSpPr>
+        <p:spPr>
+          <a:xfrm>
+            <a:off x="548640" y="1371600"/>
+            <a:ext cx="2560320" cy="2514600"/>
+          </a:xfrm>
+          <a:prstGeom prst="roundRect">
+            <a:avLst>
+              <a:gd name="adj" fmla="val 3273"/>
+            </a:avLst>
+          </a:prstGeom>
+          <a:solidFill>
+            <a:srgbClr val="EEF3FB"/>
+          </a:solidFill>
+          <a:ln/>
+          <a:effectLst>
+            <a:outerShdw sx="100000" sy="100000" kx="0" ky="0" algn="bl" rotWithShape="0" blurRad="88900" dist="25400" dir="2700000">
+              <a:srgbClr val="000000">
+                <a:alpha val="14000"/>
+              </a:srgbClr>
+            </a:outerShdw>
+          </a:effectLst>
+        </p:spPr>
+      </p:sp>
+      <p:sp>
+        <p:nvSpPr>
+          <p:cNvPr id="5" name="Text 3"/>
+          <p:cNvSpPr/>
+          <p:nvPr/>
+        </p:nvSpPr>
+        <p:spPr>
+          <a:xfrm>
+            <a:off x="749808" y="1536192"/>
+            <a:ext cx="2194560" cy="502920"/>
+          </a:xfrm>
+          <a:prstGeom prst="rect">
+            <a:avLst/>
+          </a:prstGeom>
+          <a:noFill/>
+          <a:ln/>
+        </p:spPr>
+        <p:txBody>
+          <a:bodyPr wrap="square" lIns="0" tIns="0" rIns="0" bIns="0" rtlCol="0" anchor="ctr"/>
+          <a:lstStyle/>
+          <a:p>
+            <a:pPr indent="0" marL="0">
+              <a:buNone/>
+            </a:pPr>
+            <a:r>
+              <a:rPr lang="en-US" sz="1350" b="1" dirty="0">
+                <a:solidFill>
+                  <a:srgbClr val="1E2761"/>
+                </a:solidFill>
+                <a:latin typeface="Calibri" pitchFamily="34" charset="0"/>
+                <a:ea typeface="Calibri" pitchFamily="34" charset="-122"/>
+                <a:cs typeface="Calibri" pitchFamily="34" charset="-120"/>
+              </a:rPr>
+              <a:t>What the port needs</a:t>
+            </a:r>
+            <a:endParaRPr lang="en-US" sz="1350" dirty="0"/>
+          </a:p>
+        </p:txBody>
+      </p:sp>
+      <p:sp>
+        <p:nvSpPr>
+          <p:cNvPr id="6" name="Text 4"/>
+          <p:cNvSpPr/>
+          <p:nvPr/>
+        </p:nvSpPr>
+        <p:spPr>
+          <a:xfrm>
+            <a:off x="749808" y="2011680"/>
+            <a:ext cx="2240280" cy="1783080"/>
+          </a:xfrm>
+          <a:prstGeom prst="rect">
+            <a:avLst/>
+          </a:prstGeom>
+          <a:noFill/>
+          <a:ln/>
+        </p:spPr>
+        <p:txBody>
+          <a:bodyPr wrap="square" lIns="0" tIns="0" rIns="0" bIns="0" rtlCol="0" anchor="ctr"/>
+          <a:lstStyle/>
+          <a:p>
+            <a:pPr marL="342900" indent="-342900">
+              <a:spcAft>
+                <a:spcPts val="600"/>
+              </a:spcAft>
+              <a:buSzPct val="100000"/>
+              <a:buChar char="•"/>
+            </a:pPr>
+            <a:r>
+              <a:rPr lang="en-US" sz="1050" dirty="0">
+                <a:solidFill>
+                  <a:srgbClr val="1F2733"/>
+                </a:solidFill>
+                <a:latin typeface="Calibri" pitchFamily="34" charset="0"/>
+                <a:ea typeface="Calibri" pitchFamily="34" charset="-122"/>
+                <a:cs typeface="Calibri" pitchFamily="34" charset="-120"/>
+              </a:rPr>
+              <a:t>3 registers: fair rate R, timestamp, byte snapshot</a:t>
+            </a:r>
+            <a:endParaRPr lang="en-US" sz="1050" dirty="0"/>
+          </a:p>
+          <a:p>
+            <a:pPr marL="342900" indent="-342900">
+              <a:spcAft>
+                <a:spcPts val="600"/>
+              </a:spcAft>
+              <a:buSzPct val="100000"/>
+              <a:buChar char="•"/>
+            </a:pPr>
+            <a:r>
+              <a:rPr lang="en-US" sz="1050" dirty="0">
+                <a:solidFill>
+                  <a:srgbClr val="1F2733"/>
+                </a:solidFill>
+                <a:latin typeface="Calibri" pitchFamily="34" charset="0"/>
+                <a:ea typeface="Calibri" pitchFamily="34" charset="-122"/>
+                <a:cs typeface="Calibri" pitchFamily="34" charset="-120"/>
+              </a:rPr>
+              <a:t>dequeue-triggered update: 2 multiplies, 2 subtractions, a clamp</a:t>
+            </a:r>
+            <a:endParaRPr lang="en-US" sz="1050" dirty="0"/>
+          </a:p>
+          <a:p>
+            <a:pPr marL="342900" indent="-342900">
+              <a:spcAft>
+                <a:spcPts val="600"/>
+              </a:spcAft>
+              <a:buSzPct val="100000"/>
+              <a:buChar char="•"/>
+            </a:pPr>
+            <a:r>
+              <a:rPr lang="en-US" sz="1050" dirty="0">
+                <a:solidFill>
+                  <a:srgbClr val="1F2733"/>
+                </a:solidFill>
+                <a:latin typeface="Calibri" pitchFamily="34" charset="0"/>
+                <a:ea typeface="Calibri" pitchFamily="34" charset="-122"/>
+                <a:cs typeface="Calibri" pitchFamily="34" charset="-120"/>
+              </a:rPr>
+              <a:t>per packet: one 64-bit compare-and-write (path-min)</a:t>
+            </a:r>
+            <a:endParaRPr lang="en-US" sz="1050" dirty="0"/>
+          </a:p>
+        </p:txBody>
+      </p:sp>
+      <p:sp>
+        <p:nvSpPr>
+          <p:cNvPr id="7" name="Shape 5"/>
+          <p:cNvSpPr/>
+          <p:nvPr/>
+        </p:nvSpPr>
+        <p:spPr>
+          <a:xfrm>
+            <a:off x="3337560" y="1371600"/>
+            <a:ext cx="2560320" cy="2514600"/>
+          </a:xfrm>
+          <a:prstGeom prst="roundRect">
+            <a:avLst>
+              <a:gd name="adj" fmla="val 3273"/>
+            </a:avLst>
+          </a:prstGeom>
+          <a:solidFill>
+            <a:srgbClr val="EEF3FB"/>
+          </a:solidFill>
+          <a:ln/>
+          <a:effectLst>
+            <a:outerShdw sx="100000" sy="100000" kx="0" ky="0" algn="bl" rotWithShape="0" blurRad="88900" dist="25400" dir="2700000">
+              <a:srgbClr val="000000">
+                <a:alpha val="14000"/>
+              </a:srgbClr>
+            </a:outerShdw>
+          </a:effectLst>
+        </p:spPr>
+      </p:sp>
+      <p:sp>
+        <p:nvSpPr>
+          <p:cNvPr id="8" name="Text 6"/>
+          <p:cNvSpPr/>
+          <p:nvPr/>
+        </p:nvSpPr>
+        <p:spPr>
+          <a:xfrm>
+            <a:off x="3538728" y="1536192"/>
+            <a:ext cx="2194560" cy="502920"/>
+          </a:xfrm>
+          <a:prstGeom prst="rect">
+            <a:avLst/>
+          </a:prstGeom>
+          <a:noFill/>
+          <a:ln/>
+        </p:spPr>
+        <p:txBody>
+          <a:bodyPr wrap="square" lIns="0" tIns="0" rIns="0" bIns="0" rtlCol="0" anchor="ctr"/>
+          <a:lstStyle/>
+          <a:p>
+            <a:pPr indent="0" marL="0">
+              <a:buNone/>
+            </a:pPr>
+            <a:r>
+              <a:rPr lang="en-US" sz="1350" b="1" dirty="0">
+                <a:solidFill>
+                  <a:srgbClr val="1E2761"/>
+                </a:solidFill>
+                <a:latin typeface="Calibri" pitchFamily="34" charset="0"/>
+                <a:ea typeface="Calibri" pitchFamily="34" charset="-122"/>
+                <a:cs typeface="Calibri" pitchFamily="34" charset="-120"/>
+              </a:rPr>
+              <a:t>Fixed-point build (fs_fixed_point)</a:t>
+            </a:r>
+            <a:endParaRPr lang="en-US" sz="1350" dirty="0"/>
+          </a:p>
+        </p:txBody>
+      </p:sp>
+      <p:sp>
+        <p:nvSpPr>
+          <p:cNvPr id="9" name="Text 7"/>
+          <p:cNvSpPr/>
+          <p:nvPr/>
+        </p:nvSpPr>
+        <p:spPr>
+          <a:xfrm>
+            <a:off x="3538728" y="2011680"/>
+            <a:ext cx="2240280" cy="1783080"/>
+          </a:xfrm>
+          <a:prstGeom prst="rect">
+            <a:avLst/>
+          </a:prstGeom>
+          <a:noFill/>
+          <a:ln/>
+        </p:spPr>
+        <p:txBody>
+          <a:bodyPr wrap="square" lIns="0" tIns="0" rIns="0" bIns="0" rtlCol="0" anchor="ctr"/>
+          <a:lstStyle/>
+          <a:p>
+            <a:pPr marL="342900" indent="-342900">
+              <a:spcAft>
+                <a:spcPts val="600"/>
+              </a:spcAft>
+              <a:buSzPct val="100000"/>
+              <a:buChar char="•"/>
+            </a:pPr>
+            <a:r>
+              <a:rPr lang="en-US" sz="1050" dirty="0">
+                <a:solidFill>
+                  <a:srgbClr val="1F2733"/>
+                </a:solidFill>
+                <a:latin typeface="Calibri" pitchFamily="34" charset="0"/>
+                <a:ea typeface="Calibri" pitchFamily="34" charset="-122"/>
+                <a:cs typeface="Calibri" pitchFamily="34" charset="-120"/>
+              </a:rPr>
+              <a:t>Q16 multiplier; precomputed 1/C and β/(dC)</a:t>
+            </a:r>
+            <a:endParaRPr lang="en-US" sz="1050" dirty="0"/>
+          </a:p>
+          <a:p>
+            <a:pPr marL="342900" indent="-342900">
+              <a:spcAft>
+                <a:spcPts val="600"/>
+              </a:spcAft>
+              <a:buSzPct val="100000"/>
+              <a:buChar char="•"/>
+            </a:pPr>
+            <a:r>
+              <a:rPr lang="en-US" sz="1050" dirty="0">
+                <a:solidFill>
+                  <a:srgbClr val="1F2733"/>
+                </a:solidFill>
+                <a:latin typeface="Calibri" pitchFamily="34" charset="0"/>
+                <a:ea typeface="Calibri" pitchFamily="34" charset="-122"/>
+                <a:cs typeface="Calibri" pitchFamily="34" charset="-120"/>
+              </a:rPr>
+              <a:t>reciprocal of the elapsed interval: shift + 8-entry mantissa LUT (≤ 25% max error)</a:t>
+            </a:r>
+            <a:endParaRPr lang="en-US" sz="1050" dirty="0"/>
+          </a:p>
+          <a:p>
+            <a:pPr marL="342900" indent="-342900">
+              <a:spcAft>
+                <a:spcPts val="600"/>
+              </a:spcAft>
+              <a:buSzPct val="100000"/>
+              <a:buChar char="•"/>
+            </a:pPr>
+            <a:r>
+              <a:rPr lang="en-US" sz="1050" dirty="0">
+                <a:solidFill>
+                  <a:srgbClr val="1F2733"/>
+                </a:solidFill>
+                <a:latin typeface="Calibri" pitchFamily="34" charset="0"/>
+                <a:ea typeface="Calibri" pitchFamily="34" charset="-122"/>
+                <a:cs typeface="Calibri" pitchFamily="34" charset="-120"/>
+              </a:rPr>
+              <a:t>no divider anywhere on the update path</a:t>
+            </a:r>
+            <a:endParaRPr lang="en-US" sz="1050" dirty="0"/>
+          </a:p>
+        </p:txBody>
+      </p:sp>
+      <p:sp>
+        <p:nvSpPr>
+          <p:cNvPr id="10" name="Shape 8"/>
+          <p:cNvSpPr/>
+          <p:nvPr/>
+        </p:nvSpPr>
+        <p:spPr>
+          <a:xfrm>
+            <a:off x="6126480" y="1371600"/>
+            <a:ext cx="2560320" cy="2514600"/>
+          </a:xfrm>
+          <a:prstGeom prst="roundRect">
+            <a:avLst>
+              <a:gd name="adj" fmla="val 3273"/>
+            </a:avLst>
+          </a:prstGeom>
+          <a:solidFill>
+            <a:srgbClr val="E9F0F8"/>
+          </a:solidFill>
+          <a:ln/>
+          <a:effectLst>
+            <a:outerShdw sx="100000" sy="100000" kx="0" ky="0" algn="bl" rotWithShape="0" blurRad="88900" dist="25400" dir="2700000">
+              <a:srgbClr val="000000">
+                <a:alpha val="14000"/>
+              </a:srgbClr>
+            </a:outerShdw>
+          </a:effectLst>
+        </p:spPr>
+      </p:sp>
+      <p:sp>
+        <p:nvSpPr>
+          <p:cNvPr id="11" name="Text 9"/>
+          <p:cNvSpPr/>
+          <p:nvPr/>
+        </p:nvSpPr>
+        <p:spPr>
+          <a:xfrm>
+            <a:off x="6327648" y="1536192"/>
+            <a:ext cx="2194560" cy="502920"/>
+          </a:xfrm>
+          <a:prstGeom prst="rect">
+            <a:avLst/>
+          </a:prstGeom>
+          <a:noFill/>
+          <a:ln/>
+        </p:spPr>
+        <p:txBody>
+          <a:bodyPr wrap="square" lIns="0" tIns="0" rIns="0" bIns="0" rtlCol="0" anchor="ctr"/>
+          <a:lstStyle/>
+          <a:p>
+            <a:pPr indent="0" marL="0">
+              <a:buNone/>
+            </a:pPr>
+            <a:r>
+              <a:rPr lang="en-US" sz="1350" b="1" dirty="0">
+                <a:solidFill>
+                  <a:srgbClr val="1E2761"/>
+                </a:solidFill>
+                <a:latin typeface="Calibri" pitchFamily="34" charset="0"/>
+                <a:ea typeface="Calibri" pitchFamily="34" charset="-122"/>
+                <a:cs typeface="Calibri" pitchFamily="34" charset="-120"/>
+              </a:rPr>
+              <a:t>Same results as float</a:t>
+            </a:r>
+            <a:endParaRPr lang="en-US" sz="1350" dirty="0"/>
+          </a:p>
+        </p:txBody>
+      </p:sp>
+      <p:sp>
+        <p:nvSpPr>
+          <p:cNvPr id="12" name="Text 10"/>
+          <p:cNvSpPr/>
+          <p:nvPr/>
+        </p:nvSpPr>
+        <p:spPr>
+          <a:xfrm>
+            <a:off x="6327648" y="2011680"/>
+            <a:ext cx="2240280" cy="1783080"/>
+          </a:xfrm>
+          <a:prstGeom prst="rect">
+            <a:avLst/>
+          </a:prstGeom>
+          <a:noFill/>
+          <a:ln/>
+        </p:spPr>
+        <p:txBody>
+          <a:bodyPr wrap="square" lIns="0" tIns="0" rIns="0" bIns="0" rtlCol="0" anchor="ctr"/>
+          <a:lstStyle/>
+          <a:p>
+            <a:pPr marL="342900" indent="-342900">
+              <a:spcAft>
+                <a:spcPts val="600"/>
+              </a:spcAft>
+              <a:buSzPct val="100000"/>
+              <a:buChar char="•"/>
+            </a:pPr>
+            <a:r>
+              <a:rPr lang="en-US" sz="1050" dirty="0">
+                <a:solidFill>
+                  <a:srgbClr val="1F2733"/>
+                </a:solidFill>
+                <a:latin typeface="Calibri" pitchFamily="34" charset="0"/>
+                <a:ea typeface="Calibri" pitchFamily="34" charset="-122"/>
+                <a:cs typeface="Calibri" pitchFamily="34" charset="-120"/>
+              </a:rPr>
+              <a:t>N-sweep 1.001–1.004× (float: 1.003–1.005×)</a:t>
+            </a:r>
+            <a:endParaRPr lang="en-US" sz="1050" dirty="0"/>
+          </a:p>
+          <a:p>
+            <a:pPr marL="342900" indent="-342900">
+              <a:spcAft>
+                <a:spcPts val="600"/>
+              </a:spcAft>
+              <a:buSzPct val="100000"/>
+              <a:buChar char="•"/>
+            </a:pPr>
+            <a:r>
+              <a:rPr lang="en-US" sz="1050" dirty="0">
+                <a:solidFill>
+                  <a:srgbClr val="1F2733"/>
+                </a:solidFill>
+                <a:latin typeface="Calibri" pitchFamily="34" charset="0"/>
+                <a:ea typeface="Calibri" pitchFamily="34" charset="-122"/>
+                <a:cs typeface="Calibri" pitchFamily="34" charset="-120"/>
+              </a:rPr>
+              <a:t>ring JCT within 0.9%; damped fan-in 0.81 vs 0.84</a:t>
+            </a:r>
+            <a:endParaRPr lang="en-US" sz="1050" dirty="0"/>
+          </a:p>
+          <a:p>
+            <a:pPr marL="342900" indent="-342900">
+              <a:spcAft>
+                <a:spcPts val="600"/>
+              </a:spcAft>
+              <a:buSzPct val="100000"/>
+              <a:buChar char="•"/>
+            </a:pPr>
+            <a:r>
+              <a:rPr lang="en-US" sz="1050" dirty="0">
+                <a:solidFill>
+                  <a:srgbClr val="1F2733"/>
+                </a:solidFill>
+                <a:latin typeface="Calibri" pitchFamily="34" charset="0"/>
+                <a:ea typeface="Calibri" pitchFamily="34" charset="-122"/>
+                <a:cs typeface="Calibri" pitchFamily="34" charset="-120"/>
+              </a:rPr>
+              <a:t>idle ports: update idles to 2²⁰·d — probe 0.378 vs 0.373 ms</a:t>
+            </a:r>
+            <a:endParaRPr lang="en-US" sz="1050" dirty="0"/>
+          </a:p>
+        </p:txBody>
+      </p:sp>
+      <p:sp>
+        <p:nvSpPr>
+          <p:cNvPr id="13" name="Shape 11"/>
+          <p:cNvSpPr/>
+          <p:nvPr/>
+        </p:nvSpPr>
+        <p:spPr>
+          <a:xfrm>
+            <a:off x="548640" y="4069080"/>
+            <a:ext cx="8092440" cy="685800"/>
+          </a:xfrm>
+          <a:prstGeom prst="roundRect">
+            <a:avLst>
+              <a:gd name="adj" fmla="val 12000"/>
+            </a:avLst>
+          </a:prstGeom>
+          <a:solidFill>
+            <a:srgbClr val="F7E9E8"/>
+          </a:solidFill>
+          <a:ln/>
+          <a:effectLst>
+            <a:outerShdw sx="100000" sy="100000" kx="0" ky="0" algn="bl" rotWithShape="0" blurRad="88900" dist="25400" dir="2700000">
+              <a:srgbClr val="000000">
+                <a:alpha val="14000"/>
+              </a:srgbClr>
+            </a:outerShdw>
+          </a:effectLst>
+        </p:spPr>
+      </p:sp>
+      <p:sp>
+        <p:nvSpPr>
+          <p:cNvPr id="14" name="Text 12"/>
+          <p:cNvSpPr/>
+          <p:nvPr/>
+        </p:nvSpPr>
+        <p:spPr>
+          <a:xfrm>
+            <a:off x="777240" y="4114800"/>
+            <a:ext cx="7635240" cy="594360"/>
+          </a:xfrm>
+          <a:prstGeom prst="rect">
+            <a:avLst/>
+          </a:prstGeom>
+          <a:noFill/>
+          <a:ln/>
+        </p:spPr>
+        <p:txBody>
+          <a:bodyPr wrap="square" lIns="0" tIns="0" rIns="0" bIns="0" rtlCol="0" anchor="ctr"/>
+          <a:lstStyle/>
+          <a:p>
+            <a:pPr indent="0" marL="0">
+              <a:buNone/>
+            </a:pPr>
+            <a:r>
+              <a:rPr lang="en-US" sz="1250" b="1" dirty="0">
+                <a:solidFill>
+                  <a:srgbClr val="C0504D"/>
+                </a:solidFill>
+                <a:latin typeface="Calibri" pitchFamily="34" charset="0"/>
+                <a:ea typeface="Calibri" pitchFamily="34" charset="-122"/>
+                <a:cs typeface="Calibri" pitchFamily="34" charset="-120"/>
+              </a:rPr>
+              <a:t>One real hazard found: </a:t>
+            </a:r>
+            <a:pPr indent="0" marL="0">
+              <a:buNone/>
+            </a:pPr>
+            <a:r>
+              <a:rPr lang="en-US" sz="1200" dirty="0">
+                <a:solidFill>
+                  <a:srgbClr val="1F2733"/>
+                </a:solidFill>
+                <a:latin typeface="Calibri" pitchFamily="34" charset="0"/>
+                <a:ea typeface="Calibri" pitchFamily="34" charset="-122"/>
+                <a:cs typeface="Calibri" pitchFamily="34" charset="-120"/>
+              </a:rPr>
+              <a:t>an R register in integer Mbps deadlocks floor recovery (growth truncates below ~2.5 Mbps). Kbps units remove it — we make 1 Kbps the required granularity; 32-bit unsigned Kbps spans 4.3 Tbps.</a:t>
+            </a:r>
+            <a:endParaRPr lang="en-US" sz="1250" dirty="0"/>
           </a:p>
         </p:txBody>
       </p:sp>

</xml_diff>